<commit_message>
Update Review 2 presentation to 21 pure content slides, removing viva and trivia sections
</commit_message>
<xml_diff>
--- a/Review_2_Presentation_Team.pptx
+++ b/Review_2_Presentation_Team.pptx
@@ -26,9 +26,6 @@
     <p:sldId id="274" r:id="rId25"/>
     <p:sldId id="275" r:id="rId26"/>
     <p:sldId id="276" r:id="rId27"/>
-    <p:sldId id="277" r:id="rId28"/>
-    <p:sldId id="278" r:id="rId29"/>
-    <p:sldId id="279" r:id="rId30"/>
   </p:sldIdLst>
   <p:sldSz cx="12191695" cy="6858000" type="screen4x3"/>
   <p:notesSz cx="6858000" cy="9144000"/>
@@ -4257,7 +4254,7 @@
               </a:defRPr>
             </a:pPr>
             <a:r>
-              <a:t>• Viva Takeaway: Standard deviation across folds is exceptionally low (&lt; 0.8% accuracy, &lt; 0.007 ROC-AUC), proving that performance is highly reproducible and not an artifact of an opportunistic train/test split.</a:t>
+              <a:t>• Performance Stability Analysis: Standard deviation across folds is exceptionally low (&lt; 0.8% accuracy, &lt; 0.007 ROC-AUC), proving that performance is highly reproducible and statistically generalizable.</a:t>
             </a:r>
           </a:p>
         </p:txBody>
@@ -5997,7 +5994,7 @@
               </a:defRPr>
             </a:pPr>
             <a:r>
-              <a:t>Member 3 Technical Proof: Guarantees that Recency, Frequency, and Monetary contribute equally to centroid convergence.</a:t>
+              <a:t>Mathematical Proof: Guarantees that Recency, Frequency, and Monetary contribute equally to centroid convergence.</a:t>
             </a:r>
           </a:p>
         </p:txBody>
@@ -9234,7 +9231,7 @@
               </a:defRPr>
             </a:pPr>
             <a:r>
-              <a:t>• Viva Key Takeaway: Notice how Cluster 1 achieved 100% repeat buyers and Cluster 2 captured 75.1% of all one-time buyers completely unguided! This proves that K-Means independently extracted genuine customer retention dynamics.</a:t>
+              <a:t>• Validation Finding: Notice how Cluster 1 achieved 100% repeat buyers and Cluster 2 captured 75.1% of all one-time buyers completely unguided. This confirms that K-Means independently extracted genuine customer retention dynamics.</a:t>
             </a:r>
           </a:p>
         </p:txBody>
@@ -9466,7 +9463,7 @@
               </a:defRPr>
             </a:pPr>
             <a:r>
-              <a:t>OWNERSHIP: Classification Track Part B &amp; Benchmark</a:t>
+              <a:t>OWNERSHIP: Classification Part B &amp; 10-Model Benchmark</a:t>
             </a:r>
           </a:p>
         </p:txBody>
@@ -10878,1311 +10875,6 @@
               </a:defRPr>
             </a:pPr>
             <a:r>
-              <a:t>SECTION D: VIVA VOCE READINESS (RUBRIC D2)</a:t>
-            </a:r>
-          </a:p>
-        </p:txBody>
-      </p:sp>
-      <p:sp>
-        <p:nvSpPr>
-          <p:cNvPr id="3" name="Rounded Rectangle 2"/>
-          <p:cNvSpPr/>
-          <p:nvPr/>
-        </p:nvSpPr>
-        <p:spPr>
-          <a:xfrm>
-            <a:off x="8686800" y="365760"/>
-            <a:ext cx="2743200" cy="320040"/>
-          </a:xfrm>
-          <a:prstGeom prst="roundRect">
-            <a:avLst/>
-          </a:prstGeom>
-          <a:solidFill>
-            <a:srgbClr val="E0E7FF"/>
-          </a:solidFill>
-          <a:ln w="12700">
-            <a:solidFill>
-              <a:srgbClr val="2563EB"/>
-            </a:solidFill>
-          </a:ln>
-        </p:spPr>
-        <p:style>
-          <a:lnRef idx="1">
-            <a:schemeClr val="accent1"/>
-          </a:lnRef>
-          <a:fillRef idx="3">
-            <a:schemeClr val="accent1"/>
-          </a:fillRef>
-          <a:effectRef idx="2">
-            <a:schemeClr val="accent1"/>
-          </a:effectRef>
-          <a:fontRef idx="minor">
-            <a:schemeClr val="lt1"/>
-          </a:fontRef>
-        </p:style>
-        <p:txBody>
-          <a:bodyPr rtlCol="0" anchor="ctr"/>
-          <a:lstStyle/>
-          <a:p>
-            <a:pPr algn="ctr">
-              <a:defRPr sz="950" b="1">
-                <a:solidFill>
-                  <a:srgbClr val="1E3A8A"/>
-                </a:solidFill>
-              </a:defRPr>
-            </a:pPr>
-            <a:r>
-              <a:t>Defended by: Member 1</a:t>
-            </a:r>
-          </a:p>
-        </p:txBody>
-      </p:sp>
-      <p:sp>
-        <p:nvSpPr>
-          <p:cNvPr id="4" name="TextBox 3"/>
-          <p:cNvSpPr txBox="1"/>
-          <p:nvPr/>
-        </p:nvSpPr>
-        <p:spPr>
-          <a:xfrm>
-            <a:off x="731520" y="685800"/>
-            <a:ext cx="10698480" cy="594360"/>
-          </a:xfrm>
-          <a:prstGeom prst="rect">
-            <a:avLst/>
-          </a:prstGeom>
-          <a:noFill/>
-        </p:spPr>
-        <p:txBody>
-          <a:bodyPr wrap="square">
-            <a:spAutoFit/>
-          </a:bodyPr>
-          <a:lstStyle/>
-          <a:p>
-            <a:pPr>
-              <a:defRPr sz="2200" b="1">
-                <a:solidFill>
-                  <a:srgbClr val="0F172A"/>
-                </a:solidFill>
-              </a:defRPr>
-            </a:pPr>
-            <a:r>
-              <a:t>Viva Defense Guide: Classification Track Q&amp;A</a:t>
-            </a:r>
-          </a:p>
-        </p:txBody>
-      </p:sp>
-      <p:sp>
-        <p:nvSpPr>
-          <p:cNvPr id="5" name="TextBox 4"/>
-          <p:cNvSpPr txBox="1"/>
-          <p:nvPr/>
-        </p:nvSpPr>
-        <p:spPr>
-          <a:xfrm>
-            <a:off x="731520" y="1234440"/>
-            <a:ext cx="10698480" cy="365760"/>
-          </a:xfrm>
-          <a:prstGeom prst="rect">
-            <a:avLst/>
-          </a:prstGeom>
-          <a:noFill/>
-        </p:spPr>
-        <p:txBody>
-          <a:bodyPr wrap="none">
-            <a:spAutoFit/>
-          </a:bodyPr>
-          <a:lstStyle/>
-          <a:p>
-            <a:pPr>
-              <a:defRPr sz="1200">
-                <a:solidFill>
-                  <a:srgbClr val="475569"/>
-                </a:solidFill>
-              </a:defRPr>
-            </a:pPr>
-            <a:r>
-              <a:t>Prepared answers for technical examiner questions on model architectures and evaluation.</a:t>
-            </a:r>
-          </a:p>
-        </p:txBody>
-      </p:sp>
-      <p:sp>
-        <p:nvSpPr>
-          <p:cNvPr id="6" name="Rounded Rectangle 5"/>
-          <p:cNvSpPr/>
-          <p:nvPr/>
-        </p:nvSpPr>
-        <p:spPr>
-          <a:xfrm>
-            <a:off x="731520" y="1828800"/>
-            <a:ext cx="5120640" cy="4389120"/>
-          </a:xfrm>
-          <a:prstGeom prst="roundRect">
-            <a:avLst/>
-          </a:prstGeom>
-          <a:solidFill>
-            <a:srgbClr val="F1F5F9"/>
-          </a:solidFill>
-          <a:ln w="12700">
-            <a:solidFill>
-              <a:srgbClr val="CBD5E1"/>
-            </a:solidFill>
-          </a:ln>
-        </p:spPr>
-        <p:style>
-          <a:lnRef idx="1">
-            <a:schemeClr val="accent1"/>
-          </a:lnRef>
-          <a:fillRef idx="3">
-            <a:schemeClr val="accent1"/>
-          </a:fillRef>
-          <a:effectRef idx="2">
-            <a:schemeClr val="accent1"/>
-          </a:effectRef>
-          <a:fontRef idx="minor">
-            <a:schemeClr val="lt1"/>
-          </a:fontRef>
-        </p:style>
-        <p:txBody>
-          <a:bodyPr rtlCol="0" anchor="ctr"/>
-          <a:lstStyle/>
-          <a:p>
-            <a:pPr algn="ctr"/>
-          </a:p>
-        </p:txBody>
-      </p:sp>
-      <p:sp>
-        <p:nvSpPr>
-          <p:cNvPr id="7" name="TextBox 6"/>
-          <p:cNvSpPr txBox="1"/>
-          <p:nvPr/>
-        </p:nvSpPr>
-        <p:spPr>
-          <a:xfrm>
-            <a:off x="914400" y="2011680"/>
-            <a:ext cx="4754880" cy="4023360"/>
-          </a:xfrm>
-          <a:prstGeom prst="rect">
-            <a:avLst/>
-          </a:prstGeom>
-          <a:noFill/>
-        </p:spPr>
-        <p:txBody>
-          <a:bodyPr wrap="square">
-            <a:spAutoFit/>
-          </a:bodyPr>
-          <a:lstStyle/>
-          <a:p/>
-          <a:p>
-            <a:pPr>
-              <a:spcBef>
-                <a:spcPts val="600"/>
-              </a:spcBef>
-              <a:defRPr sz="1200" b="1">
-                <a:solidFill>
-                  <a:srgbClr val="1E3A8A"/>
-                </a:solidFill>
-              </a:defRPr>
-            </a:pPr>
-            <a:r>
-              <a:t>Q1: Why did ensemble methods outperform single Decision Trees?</a:t>
-            </a:r>
-          </a:p>
-          <a:p>
-            <a:pPr>
-              <a:spcBef>
-                <a:spcPts val="300"/>
-              </a:spcBef>
-              <a:defRPr sz="1050">
-                <a:solidFill>
-                  <a:srgbClr val="0F172A"/>
-                </a:solidFill>
-              </a:defRPr>
-            </a:pPr>
-            <a:r>
-              <a:t>A: Single decision trees have high variance and create jagged, brittle partition boundaries. Bagging/Random Forest averages across decorrelated bootstrap trees, smoothing boundaries and reducing error variance by ~1/M.</a:t>
-            </a:r>
-          </a:p>
-          <a:p>
-            <a:pPr>
-              <a:spcBef>
-                <a:spcPts val="600"/>
-              </a:spcBef>
-              <a:defRPr sz="1200" b="1">
-                <a:solidFill>
-                  <a:srgbClr val="1E3A8A"/>
-                </a:solidFill>
-              </a:defRPr>
-            </a:pPr>
-            <a:r>
-              <a:t>Q2: Why was Frequency excluded from feature set X?</a:t>
-            </a:r>
-          </a:p>
-          <a:p>
-            <a:pPr>
-              <a:spcBef>
-                <a:spcPts val="300"/>
-              </a:spcBef>
-              <a:defRPr sz="1050">
-                <a:solidFill>
-                  <a:srgbClr val="0F172A"/>
-                </a:solidFill>
-              </a:defRPr>
-            </a:pPr>
-            <a:r>
-              <a:t>A: The label Repeat_Customer was literally constructed as Frequency &gt; 1. Including Frequency in X causes 100% target leakage, converting a predictive task into a trivial rule check.</a:t>
-            </a:r>
-          </a:p>
-        </p:txBody>
-      </p:sp>
-      <p:sp>
-        <p:nvSpPr>
-          <p:cNvPr id="8" name="Rounded Rectangle 7"/>
-          <p:cNvSpPr/>
-          <p:nvPr/>
-        </p:nvSpPr>
-        <p:spPr>
-          <a:xfrm>
-            <a:off x="6217920" y="1828800"/>
-            <a:ext cx="5212080" cy="4389120"/>
-          </a:xfrm>
-          <a:prstGeom prst="roundRect">
-            <a:avLst/>
-          </a:prstGeom>
-          <a:solidFill>
-            <a:srgbClr val="F1F5F9"/>
-          </a:solidFill>
-          <a:ln w="12700">
-            <a:solidFill>
-              <a:srgbClr val="CBD5E1"/>
-            </a:solidFill>
-          </a:ln>
-        </p:spPr>
-        <p:style>
-          <a:lnRef idx="1">
-            <a:schemeClr val="accent1"/>
-          </a:lnRef>
-          <a:fillRef idx="3">
-            <a:schemeClr val="accent1"/>
-          </a:fillRef>
-          <a:effectRef idx="2">
-            <a:schemeClr val="accent1"/>
-          </a:effectRef>
-          <a:fontRef idx="minor">
-            <a:schemeClr val="lt1"/>
-          </a:fontRef>
-        </p:style>
-        <p:txBody>
-          <a:bodyPr rtlCol="0" anchor="ctr"/>
-          <a:lstStyle/>
-          <a:p>
-            <a:pPr algn="ctr"/>
-          </a:p>
-        </p:txBody>
-      </p:sp>
-      <p:sp>
-        <p:nvSpPr>
-          <p:cNvPr id="9" name="TextBox 8"/>
-          <p:cNvSpPr txBox="1"/>
-          <p:nvPr/>
-        </p:nvSpPr>
-        <p:spPr>
-          <a:xfrm>
-            <a:off x="6400800" y="2011680"/>
-            <a:ext cx="4846320" cy="4023360"/>
-          </a:xfrm>
-          <a:prstGeom prst="rect">
-            <a:avLst/>
-          </a:prstGeom>
-          <a:noFill/>
-        </p:spPr>
-        <p:txBody>
-          <a:bodyPr wrap="square">
-            <a:spAutoFit/>
-          </a:bodyPr>
-          <a:lstStyle/>
-          <a:p/>
-          <a:p>
-            <a:pPr>
-              <a:spcBef>
-                <a:spcPts val="600"/>
-              </a:spcBef>
-              <a:defRPr sz="1200" b="1">
-                <a:solidFill>
-                  <a:srgbClr val="1E3A8A"/>
-                </a:solidFill>
-              </a:defRPr>
-            </a:pPr>
-            <a:r>
-              <a:t>Q3: How does AdaBoost differ fundamentally from Gradient Boosting?</a:t>
-            </a:r>
-          </a:p>
-          <a:p>
-            <a:pPr>
-              <a:spcBef>
-                <a:spcPts val="300"/>
-              </a:spcBef>
-              <a:defRPr sz="1050">
-                <a:solidFill>
-                  <a:srgbClr val="0F172A"/>
-                </a:solidFill>
-              </a:defRPr>
-            </a:pPr>
-            <a:r>
-              <a:t>A: AdaBoost adjusts observation sample weights at each step, forcing subsequent estimators to focus on previous errors. Gradient Boosting fits new trees to the pseudo-residuals (negative gradient of the loss function) via gradient descent in function space.</a:t>
-            </a:r>
-          </a:p>
-          <a:p>
-            <a:pPr>
-              <a:spcBef>
-                <a:spcPts val="600"/>
-              </a:spcBef>
-              <a:defRPr sz="1200" b="1">
-                <a:solidFill>
-                  <a:srgbClr val="1E3A8A"/>
-                </a:solidFill>
-              </a:defRPr>
-            </a:pPr>
-            <a:r>
-              <a:t>Q4: Why did MLP achieve the highest ROC-AUC (0.9065)?</a:t>
-            </a:r>
-          </a:p>
-          <a:p>
-            <a:pPr>
-              <a:spcBef>
-                <a:spcPts val="300"/>
-              </a:spcBef>
-              <a:defRPr sz="1050">
-                <a:solidFill>
-                  <a:srgbClr val="0F172A"/>
-                </a:solidFill>
-              </a:defRPr>
-            </a:pPr>
-            <a:r>
-              <a:t>A: The feedforward neural network projects Recency and Monetary into high-dimensional hidden representations with non-linear ReLU activations, outputting continuous, finely calibrated sigmoid probabilities.</a:t>
-            </a:r>
-          </a:p>
-        </p:txBody>
-      </p:sp>
-    </p:spTree>
-  </p:cSld>
-  <p:clrMapOvr>
-    <a:masterClrMapping/>
-  </p:clrMapOvr>
-</p:sld>
-</file>
-
-<file path=ppt/slides/slide22.xml><?xml version="1.0" encoding="utf-8"?>
-<p:sld xmlns:a="http://schemas.openxmlformats.org/drawingml/2006/main" xmlns:p="http://schemas.openxmlformats.org/presentationml/2006/main" xmlns:r="http://schemas.openxmlformats.org/officeDocument/2006/relationships">
-  <p:cSld>
-    <p:spTree>
-      <p:nvGrpSpPr>
-        <p:cNvPr id="1" name=""/>
-        <p:cNvGrpSpPr/>
-        <p:nvPr/>
-      </p:nvGrpSpPr>
-      <p:grpSpPr/>
-      <p:sp>
-        <p:nvSpPr>
-          <p:cNvPr id="2" name="TextBox 1"/>
-          <p:cNvSpPr txBox="1"/>
-          <p:nvPr/>
-        </p:nvSpPr>
-        <p:spPr>
-          <a:xfrm>
-            <a:off x="731520" y="365760"/>
-            <a:ext cx="7772400" cy="320040"/>
-          </a:xfrm>
-          <a:prstGeom prst="rect">
-            <a:avLst/>
-          </a:prstGeom>
-          <a:noFill/>
-        </p:spPr>
-        <p:txBody>
-          <a:bodyPr wrap="square">
-            <a:spAutoFit/>
-          </a:bodyPr>
-          <a:lstStyle/>
-          <a:p>
-            <a:pPr>
-              <a:defRPr sz="1000" b="1">
-                <a:solidFill>
-                  <a:srgbClr val="2563EB"/>
-                </a:solidFill>
-              </a:defRPr>
-            </a:pPr>
-            <a:r>
-              <a:t>SECTION D: VIVA VOCE READINESS (RUBRIC D2)</a:t>
-            </a:r>
-          </a:p>
-        </p:txBody>
-      </p:sp>
-      <p:sp>
-        <p:nvSpPr>
-          <p:cNvPr id="3" name="Rounded Rectangle 2"/>
-          <p:cNvSpPr/>
-          <p:nvPr/>
-        </p:nvSpPr>
-        <p:spPr>
-          <a:xfrm>
-            <a:off x="8686800" y="365760"/>
-            <a:ext cx="2743200" cy="320040"/>
-          </a:xfrm>
-          <a:prstGeom prst="roundRect">
-            <a:avLst/>
-          </a:prstGeom>
-          <a:solidFill>
-            <a:srgbClr val="E0E7FF"/>
-          </a:solidFill>
-          <a:ln w="12700">
-            <a:solidFill>
-              <a:srgbClr val="2563EB"/>
-            </a:solidFill>
-          </a:ln>
-        </p:spPr>
-        <p:style>
-          <a:lnRef idx="1">
-            <a:schemeClr val="accent1"/>
-          </a:lnRef>
-          <a:fillRef idx="3">
-            <a:schemeClr val="accent1"/>
-          </a:fillRef>
-          <a:effectRef idx="2">
-            <a:schemeClr val="accent1"/>
-          </a:effectRef>
-          <a:fontRef idx="minor">
-            <a:schemeClr val="lt1"/>
-          </a:fontRef>
-        </p:style>
-        <p:txBody>
-          <a:bodyPr rtlCol="0" anchor="ctr"/>
-          <a:lstStyle/>
-          <a:p>
-            <a:pPr algn="ctr">
-              <a:defRPr sz="950" b="1">
-                <a:solidFill>
-                  <a:srgbClr val="1E3A8A"/>
-                </a:solidFill>
-              </a:defRPr>
-            </a:pPr>
-            <a:r>
-              <a:t>Defended by: Member 2</a:t>
-            </a:r>
-          </a:p>
-        </p:txBody>
-      </p:sp>
-      <p:sp>
-        <p:nvSpPr>
-          <p:cNvPr id="4" name="TextBox 3"/>
-          <p:cNvSpPr txBox="1"/>
-          <p:nvPr/>
-        </p:nvSpPr>
-        <p:spPr>
-          <a:xfrm>
-            <a:off x="731520" y="685800"/>
-            <a:ext cx="10698480" cy="594360"/>
-          </a:xfrm>
-          <a:prstGeom prst="rect">
-            <a:avLst/>
-          </a:prstGeom>
-          <a:noFill/>
-        </p:spPr>
-        <p:txBody>
-          <a:bodyPr wrap="square">
-            <a:spAutoFit/>
-          </a:bodyPr>
-          <a:lstStyle/>
-          <a:p>
-            <a:pPr>
-              <a:defRPr sz="2200" b="1">
-                <a:solidFill>
-                  <a:srgbClr val="0F172A"/>
-                </a:solidFill>
-              </a:defRPr>
-            </a:pPr>
-            <a:r>
-              <a:t>Viva Defense Guide: Tuning, MLOps &amp; Leakage Q&amp;A</a:t>
-            </a:r>
-          </a:p>
-        </p:txBody>
-      </p:sp>
-      <p:sp>
-        <p:nvSpPr>
-          <p:cNvPr id="5" name="TextBox 4"/>
-          <p:cNvSpPr txBox="1"/>
-          <p:nvPr/>
-        </p:nvSpPr>
-        <p:spPr>
-          <a:xfrm>
-            <a:off x="731520" y="1234440"/>
-            <a:ext cx="10698480" cy="365760"/>
-          </a:xfrm>
-          <a:prstGeom prst="rect">
-            <a:avLst/>
-          </a:prstGeom>
-          <a:noFill/>
-        </p:spPr>
-        <p:txBody>
-          <a:bodyPr wrap="none">
-            <a:spAutoFit/>
-          </a:bodyPr>
-          <a:lstStyle/>
-          <a:p>
-            <a:pPr>
-              <a:defRPr sz="1200">
-                <a:solidFill>
-                  <a:srgbClr val="475569"/>
-                </a:solidFill>
-              </a:defRPr>
-            </a:pPr>
-            <a:r>
-              <a:t>Prepared answers for technical examiner questions on preprocessing, tuning, and deployment.</a:t>
-            </a:r>
-          </a:p>
-        </p:txBody>
-      </p:sp>
-      <p:sp>
-        <p:nvSpPr>
-          <p:cNvPr id="6" name="Rounded Rectangle 5"/>
-          <p:cNvSpPr/>
-          <p:nvPr/>
-        </p:nvSpPr>
-        <p:spPr>
-          <a:xfrm>
-            <a:off x="731520" y="1828800"/>
-            <a:ext cx="5120640" cy="4389120"/>
-          </a:xfrm>
-          <a:prstGeom prst="roundRect">
-            <a:avLst/>
-          </a:prstGeom>
-          <a:solidFill>
-            <a:srgbClr val="F1F5F9"/>
-          </a:solidFill>
-          <a:ln w="12700">
-            <a:solidFill>
-              <a:srgbClr val="CBD5E1"/>
-            </a:solidFill>
-          </a:ln>
-        </p:spPr>
-        <p:style>
-          <a:lnRef idx="1">
-            <a:schemeClr val="accent1"/>
-          </a:lnRef>
-          <a:fillRef idx="3">
-            <a:schemeClr val="accent1"/>
-          </a:fillRef>
-          <a:effectRef idx="2">
-            <a:schemeClr val="accent1"/>
-          </a:effectRef>
-          <a:fontRef idx="minor">
-            <a:schemeClr val="lt1"/>
-          </a:fontRef>
-        </p:style>
-        <p:txBody>
-          <a:bodyPr rtlCol="0" anchor="ctr"/>
-          <a:lstStyle/>
-          <a:p>
-            <a:pPr algn="ctr"/>
-          </a:p>
-        </p:txBody>
-      </p:sp>
-      <p:sp>
-        <p:nvSpPr>
-          <p:cNvPr id="7" name="TextBox 6"/>
-          <p:cNvSpPr txBox="1"/>
-          <p:nvPr/>
-        </p:nvSpPr>
-        <p:spPr>
-          <a:xfrm>
-            <a:off x="914400" y="2011680"/>
-            <a:ext cx="4754880" cy="4023360"/>
-          </a:xfrm>
-          <a:prstGeom prst="rect">
-            <a:avLst/>
-          </a:prstGeom>
-          <a:noFill/>
-        </p:spPr>
-        <p:txBody>
-          <a:bodyPr wrap="square">
-            <a:spAutoFit/>
-          </a:bodyPr>
-          <a:lstStyle/>
-          <a:p/>
-          <a:p>
-            <a:pPr>
-              <a:spcBef>
-                <a:spcPts val="600"/>
-              </a:spcBef>
-              <a:defRPr sz="1200" b="1">
-                <a:solidFill>
-                  <a:srgbClr val="059669"/>
-                </a:solidFill>
-              </a:defRPr>
-            </a:pPr>
-            <a:r>
-              <a:t>Q1: How did GridSearchCV prevent test set data leakage?</a:t>
-            </a:r>
-          </a:p>
-          <a:p>
-            <a:pPr>
-              <a:spcBef>
-                <a:spcPts val="300"/>
-              </a:spcBef>
-              <a:defRPr sz="1050">
-                <a:solidFill>
-                  <a:srgbClr val="0F172A"/>
-                </a:solidFill>
-              </a:defRPr>
-            </a:pPr>
-            <a:r>
-              <a:t>A: The IQRClipper and StandardScaler were embedded inside an sklearn Pipeline. During GridSearchCV 5-fold cross-validation, the transformer was fitted exclusively on the 4 training folds and evaluated on the 5th validation fold.</a:t>
-            </a:r>
-          </a:p>
-          <a:p>
-            <a:pPr>
-              <a:spcBef>
-                <a:spcPts val="600"/>
-              </a:spcBef>
-              <a:defRPr sz="1200" b="1">
-                <a:solidFill>
-                  <a:srgbClr val="059669"/>
-                </a:solidFill>
-              </a:defRPr>
-            </a:pPr>
-            <a:r>
-              <a:t>Q2: Why did tuning max_depth=4 improve generalization?</a:t>
-            </a:r>
-          </a:p>
-          <a:p>
-            <a:pPr>
-              <a:spcBef>
-                <a:spcPts val="300"/>
-              </a:spcBef>
-              <a:defRPr sz="1050">
-                <a:solidFill>
-                  <a:srgbClr val="0F172A"/>
-                </a:solidFill>
-              </a:defRPr>
-            </a:pPr>
-            <a:r>
-              <a:t>A: Unconstrained trees split until leaves are pure, capturing noise in retail customer spending. Capping max_depth=4 acts as structural regularization, boosting test ROC-AUC to 0.9053.</a:t>
-            </a:r>
-          </a:p>
-        </p:txBody>
-      </p:sp>
-      <p:sp>
-        <p:nvSpPr>
-          <p:cNvPr id="8" name="Rounded Rectangle 7"/>
-          <p:cNvSpPr/>
-          <p:nvPr/>
-        </p:nvSpPr>
-        <p:spPr>
-          <a:xfrm>
-            <a:off x="6217920" y="1828800"/>
-            <a:ext cx="5212080" cy="4389120"/>
-          </a:xfrm>
-          <a:prstGeom prst="roundRect">
-            <a:avLst/>
-          </a:prstGeom>
-          <a:solidFill>
-            <a:srgbClr val="F1F5F9"/>
-          </a:solidFill>
-          <a:ln w="12700">
-            <a:solidFill>
-              <a:srgbClr val="CBD5E1"/>
-            </a:solidFill>
-          </a:ln>
-        </p:spPr>
-        <p:style>
-          <a:lnRef idx="1">
-            <a:schemeClr val="accent1"/>
-          </a:lnRef>
-          <a:fillRef idx="3">
-            <a:schemeClr val="accent1"/>
-          </a:fillRef>
-          <a:effectRef idx="2">
-            <a:schemeClr val="accent1"/>
-          </a:effectRef>
-          <a:fontRef idx="minor">
-            <a:schemeClr val="lt1"/>
-          </a:fontRef>
-        </p:style>
-        <p:txBody>
-          <a:bodyPr rtlCol="0" anchor="ctr"/>
-          <a:lstStyle/>
-          <a:p>
-            <a:pPr algn="ctr"/>
-          </a:p>
-        </p:txBody>
-      </p:sp>
-      <p:sp>
-        <p:nvSpPr>
-          <p:cNvPr id="9" name="TextBox 8"/>
-          <p:cNvSpPr txBox="1"/>
-          <p:nvPr/>
-        </p:nvSpPr>
-        <p:spPr>
-          <a:xfrm>
-            <a:off x="6400800" y="2011680"/>
-            <a:ext cx="4846320" cy="4023360"/>
-          </a:xfrm>
-          <a:prstGeom prst="rect">
-            <a:avLst/>
-          </a:prstGeom>
-          <a:noFill/>
-        </p:spPr>
-        <p:txBody>
-          <a:bodyPr wrap="square">
-            <a:spAutoFit/>
-          </a:bodyPr>
-          <a:lstStyle/>
-          <a:p/>
-          <a:p>
-            <a:pPr>
-              <a:spcBef>
-                <a:spcPts val="600"/>
-              </a:spcBef>
-              <a:defRPr sz="1200" b="1">
-                <a:solidFill>
-                  <a:srgbClr val="059669"/>
-                </a:solidFill>
-              </a:defRPr>
-            </a:pPr>
-            <a:r>
-              <a:t>Q3: Why is 5-fold CV required if we already have an 80/20 test split?</a:t>
-            </a:r>
-          </a:p>
-          <a:p>
-            <a:pPr>
-              <a:spcBef>
-                <a:spcPts val="300"/>
-              </a:spcBef>
-              <a:defRPr sz="1050">
-                <a:solidFill>
-                  <a:srgbClr val="0F172A"/>
-                </a:solidFill>
-              </a:defRPr>
-            </a:pPr>
-            <a:r>
-              <a:t>A: An 80/20 test split gives a single point estimate. 5-fold CV evaluates model variance across multiple data resamples. Our standard deviation of &lt;0.8% proves the model is statistically robust.</a:t>
-            </a:r>
-          </a:p>
-          <a:p>
-            <a:pPr>
-              <a:spcBef>
-                <a:spcPts val="600"/>
-              </a:spcBef>
-              <a:defRPr sz="1200" b="1">
-                <a:solidFill>
-                  <a:srgbClr val="059669"/>
-                </a:solidFill>
-              </a:defRPr>
-            </a:pPr>
-            <a:r>
-              <a:t>Q4: How does the production pipeline support real-time web inference?</a:t>
-            </a:r>
-          </a:p>
-          <a:p>
-            <a:pPr>
-              <a:spcBef>
-                <a:spcPts val="300"/>
-              </a:spcBef>
-              <a:defRPr sz="1050">
-                <a:solidFill>
-                  <a:srgbClr val="0F172A"/>
-                </a:solidFill>
-              </a:defRPr>
-            </a:pPr>
-            <a:r>
-              <a:t>A: The trained Pipeline (IQRClipper -&gt; StandardScaler -&gt; Tuned RF) is serialized into a standalone joblib binary. The Streamlit app takes user raw inputs, applies transforms, and predicts in &lt;15ms.</a:t>
-            </a:r>
-          </a:p>
-        </p:txBody>
-      </p:sp>
-    </p:spTree>
-  </p:cSld>
-  <p:clrMapOvr>
-    <a:masterClrMapping/>
-  </p:clrMapOvr>
-</p:sld>
-</file>
-
-<file path=ppt/slides/slide23.xml><?xml version="1.0" encoding="utf-8"?>
-<p:sld xmlns:a="http://schemas.openxmlformats.org/drawingml/2006/main" xmlns:p="http://schemas.openxmlformats.org/presentationml/2006/main" xmlns:r="http://schemas.openxmlformats.org/officeDocument/2006/relationships">
-  <p:cSld>
-    <p:spTree>
-      <p:nvGrpSpPr>
-        <p:cNvPr id="1" name=""/>
-        <p:cNvGrpSpPr/>
-        <p:nvPr/>
-      </p:nvGrpSpPr>
-      <p:grpSpPr/>
-      <p:sp>
-        <p:nvSpPr>
-          <p:cNvPr id="2" name="TextBox 1"/>
-          <p:cNvSpPr txBox="1"/>
-          <p:nvPr/>
-        </p:nvSpPr>
-        <p:spPr>
-          <a:xfrm>
-            <a:off x="731520" y="365760"/>
-            <a:ext cx="7772400" cy="320040"/>
-          </a:xfrm>
-          <a:prstGeom prst="rect">
-            <a:avLst/>
-          </a:prstGeom>
-          <a:noFill/>
-        </p:spPr>
-        <p:txBody>
-          <a:bodyPr wrap="square">
-            <a:spAutoFit/>
-          </a:bodyPr>
-          <a:lstStyle/>
-          <a:p>
-            <a:pPr>
-              <a:defRPr sz="1000" b="1">
-                <a:solidFill>
-                  <a:srgbClr val="2563EB"/>
-                </a:solidFill>
-              </a:defRPr>
-            </a:pPr>
-            <a:r>
-              <a:t>SECTION D: VIVA VOCE READINESS (RUBRIC D2)</a:t>
-            </a:r>
-          </a:p>
-        </p:txBody>
-      </p:sp>
-      <p:sp>
-        <p:nvSpPr>
-          <p:cNvPr id="3" name="Rounded Rectangle 2"/>
-          <p:cNvSpPr/>
-          <p:nvPr/>
-        </p:nvSpPr>
-        <p:spPr>
-          <a:xfrm>
-            <a:off x="8686800" y="365760"/>
-            <a:ext cx="2743200" cy="320040"/>
-          </a:xfrm>
-          <a:prstGeom prst="roundRect">
-            <a:avLst/>
-          </a:prstGeom>
-          <a:solidFill>
-            <a:srgbClr val="E0E7FF"/>
-          </a:solidFill>
-          <a:ln w="12700">
-            <a:solidFill>
-              <a:srgbClr val="2563EB"/>
-            </a:solidFill>
-          </a:ln>
-        </p:spPr>
-        <p:style>
-          <a:lnRef idx="1">
-            <a:schemeClr val="accent1"/>
-          </a:lnRef>
-          <a:fillRef idx="3">
-            <a:schemeClr val="accent1"/>
-          </a:fillRef>
-          <a:effectRef idx="2">
-            <a:schemeClr val="accent1"/>
-          </a:effectRef>
-          <a:fontRef idx="minor">
-            <a:schemeClr val="lt1"/>
-          </a:fontRef>
-        </p:style>
-        <p:txBody>
-          <a:bodyPr rtlCol="0" anchor="ctr"/>
-          <a:lstStyle/>
-          <a:p>
-            <a:pPr algn="ctr">
-              <a:defRPr sz="950" b="1">
-                <a:solidFill>
-                  <a:srgbClr val="1E3A8A"/>
-                </a:solidFill>
-              </a:defRPr>
-            </a:pPr>
-            <a:r>
-              <a:t>Defended by: Member 3</a:t>
-            </a:r>
-          </a:p>
-        </p:txBody>
-      </p:sp>
-      <p:sp>
-        <p:nvSpPr>
-          <p:cNvPr id="4" name="TextBox 3"/>
-          <p:cNvSpPr txBox="1"/>
-          <p:nvPr/>
-        </p:nvSpPr>
-        <p:spPr>
-          <a:xfrm>
-            <a:off x="731520" y="685800"/>
-            <a:ext cx="10698480" cy="594360"/>
-          </a:xfrm>
-          <a:prstGeom prst="rect">
-            <a:avLst/>
-          </a:prstGeom>
-          <a:noFill/>
-        </p:spPr>
-        <p:txBody>
-          <a:bodyPr wrap="square">
-            <a:spAutoFit/>
-          </a:bodyPr>
-          <a:lstStyle/>
-          <a:p>
-            <a:pPr>
-              <a:defRPr sz="2200" b="1">
-                <a:solidFill>
-                  <a:srgbClr val="0F172A"/>
-                </a:solidFill>
-              </a:defRPr>
-            </a:pPr>
-            <a:r>
-              <a:t>Viva Defense Guide: Clustering Track Q&amp;A</a:t>
-            </a:r>
-          </a:p>
-        </p:txBody>
-      </p:sp>
-      <p:sp>
-        <p:nvSpPr>
-          <p:cNvPr id="5" name="TextBox 4"/>
-          <p:cNvSpPr txBox="1"/>
-          <p:nvPr/>
-        </p:nvSpPr>
-        <p:spPr>
-          <a:xfrm>
-            <a:off x="731520" y="1234440"/>
-            <a:ext cx="10698480" cy="365760"/>
-          </a:xfrm>
-          <a:prstGeom prst="rect">
-            <a:avLst/>
-          </a:prstGeom>
-          <a:noFill/>
-        </p:spPr>
-        <p:txBody>
-          <a:bodyPr wrap="none">
-            <a:spAutoFit/>
-          </a:bodyPr>
-          <a:lstStyle/>
-          <a:p>
-            <a:pPr>
-              <a:defRPr sz="1200">
-                <a:solidFill>
-                  <a:srgbClr val="475569"/>
-                </a:solidFill>
-              </a:defRPr>
-            </a:pPr>
-            <a:r>
-              <a:t>Prepared answers for technical examiner questions on clustering mathematics and validation.</a:t>
-            </a:r>
-          </a:p>
-        </p:txBody>
-      </p:sp>
-      <p:sp>
-        <p:nvSpPr>
-          <p:cNvPr id="6" name="Rounded Rectangle 5"/>
-          <p:cNvSpPr/>
-          <p:nvPr/>
-        </p:nvSpPr>
-        <p:spPr>
-          <a:xfrm>
-            <a:off x="731520" y="1828800"/>
-            <a:ext cx="5120640" cy="4389120"/>
-          </a:xfrm>
-          <a:prstGeom prst="roundRect">
-            <a:avLst/>
-          </a:prstGeom>
-          <a:solidFill>
-            <a:srgbClr val="F1F5F9"/>
-          </a:solidFill>
-          <a:ln w="12700">
-            <a:solidFill>
-              <a:srgbClr val="CBD5E1"/>
-            </a:solidFill>
-          </a:ln>
-        </p:spPr>
-        <p:style>
-          <a:lnRef idx="1">
-            <a:schemeClr val="accent1"/>
-          </a:lnRef>
-          <a:fillRef idx="3">
-            <a:schemeClr val="accent1"/>
-          </a:fillRef>
-          <a:effectRef idx="2">
-            <a:schemeClr val="accent1"/>
-          </a:effectRef>
-          <a:fontRef idx="minor">
-            <a:schemeClr val="lt1"/>
-          </a:fontRef>
-        </p:style>
-        <p:txBody>
-          <a:bodyPr rtlCol="0" anchor="ctr"/>
-          <a:lstStyle/>
-          <a:p>
-            <a:pPr algn="ctr"/>
-          </a:p>
-        </p:txBody>
-      </p:sp>
-      <p:sp>
-        <p:nvSpPr>
-          <p:cNvPr id="7" name="TextBox 6"/>
-          <p:cNvSpPr txBox="1"/>
-          <p:nvPr/>
-        </p:nvSpPr>
-        <p:spPr>
-          <a:xfrm>
-            <a:off x="914400" y="2011680"/>
-            <a:ext cx="4754880" cy="4023360"/>
-          </a:xfrm>
-          <a:prstGeom prst="rect">
-            <a:avLst/>
-          </a:prstGeom>
-          <a:noFill/>
-        </p:spPr>
-        <p:txBody>
-          <a:bodyPr wrap="square">
-            <a:spAutoFit/>
-          </a:bodyPr>
-          <a:lstStyle/>
-          <a:p/>
-          <a:p>
-            <a:pPr>
-              <a:spcBef>
-                <a:spcPts val="600"/>
-              </a:spcBef>
-              <a:defRPr sz="1200" b="1">
-                <a:solidFill>
-                  <a:srgbClr val="7C3AED"/>
-                </a:solidFill>
-              </a:defRPr>
-            </a:pPr>
-            <a:r>
-              <a:t>Q1: Why did Complete Linkage fail compared to Ward Linkage?</a:t>
-            </a:r>
-          </a:p>
-          <a:p>
-            <a:pPr>
-              <a:spcBef>
-                <a:spcPts val="300"/>
-              </a:spcBef>
-              <a:defRPr sz="1050">
-                <a:solidFill>
-                  <a:srgbClr val="0F172A"/>
-                </a:solidFill>
-              </a:defRPr>
-            </a:pPr>
-            <a:r>
-              <a:t>A: Complete linkage evaluates maximum pairwise distance between clusters. A single extreme outlier forces early merging or chaining, yielding a low Silhouette Score (0.1134). Ward linkage minimizes within-cluster variance, producing compact, balanced spherical clusters.</a:t>
-            </a:r>
-          </a:p>
-          <a:p>
-            <a:pPr>
-              <a:spcBef>
-                <a:spcPts val="600"/>
-              </a:spcBef>
-              <a:defRPr sz="1200" b="1">
-                <a:solidFill>
-                  <a:srgbClr val="7C3AED"/>
-                </a:solidFill>
-              </a:defRPr>
-            </a:pPr>
-            <a:r>
-              <a:t>Q2: What is the difference between Davies-Bouldin and Silhouette Score?</a:t>
-            </a:r>
-          </a:p>
-          <a:p>
-            <a:pPr>
-              <a:spcBef>
-                <a:spcPts val="300"/>
-              </a:spcBef>
-              <a:defRPr sz="1050">
-                <a:solidFill>
-                  <a:srgbClr val="0F172A"/>
-                </a:solidFill>
-              </a:defRPr>
-            </a:pPr>
-            <a:r>
-              <a:t>A: Silhouette score measures individual point cohesion vs separation (higher is better, [-1, 1]). Davies-Bouldin measures average cluster similarity ratio between within-cluster spread and centroid separation (lower is better, &gt;= 0).</a:t>
-            </a:r>
-          </a:p>
-        </p:txBody>
-      </p:sp>
-      <p:sp>
-        <p:nvSpPr>
-          <p:cNvPr id="8" name="Rounded Rectangle 7"/>
-          <p:cNvSpPr/>
-          <p:nvPr/>
-        </p:nvSpPr>
-        <p:spPr>
-          <a:xfrm>
-            <a:off x="6217920" y="1828800"/>
-            <a:ext cx="5212080" cy="4389120"/>
-          </a:xfrm>
-          <a:prstGeom prst="roundRect">
-            <a:avLst/>
-          </a:prstGeom>
-          <a:solidFill>
-            <a:srgbClr val="F1F5F9"/>
-          </a:solidFill>
-          <a:ln w="12700">
-            <a:solidFill>
-              <a:srgbClr val="CBD5E1"/>
-            </a:solidFill>
-          </a:ln>
-        </p:spPr>
-        <p:style>
-          <a:lnRef idx="1">
-            <a:schemeClr val="accent1"/>
-          </a:lnRef>
-          <a:fillRef idx="3">
-            <a:schemeClr val="accent1"/>
-          </a:fillRef>
-          <a:effectRef idx="2">
-            <a:schemeClr val="accent1"/>
-          </a:effectRef>
-          <a:fontRef idx="minor">
-            <a:schemeClr val="lt1"/>
-          </a:fontRef>
-        </p:style>
-        <p:txBody>
-          <a:bodyPr rtlCol="0" anchor="ctr"/>
-          <a:lstStyle/>
-          <a:p>
-            <a:pPr algn="ctr"/>
-          </a:p>
-        </p:txBody>
-      </p:sp>
-      <p:sp>
-        <p:nvSpPr>
-          <p:cNvPr id="9" name="TextBox 8"/>
-          <p:cNvSpPr txBox="1"/>
-          <p:nvPr/>
-        </p:nvSpPr>
-        <p:spPr>
-          <a:xfrm>
-            <a:off x="6400800" y="2011680"/>
-            <a:ext cx="4846320" cy="4023360"/>
-          </a:xfrm>
-          <a:prstGeom prst="rect">
-            <a:avLst/>
-          </a:prstGeom>
-          <a:noFill/>
-        </p:spPr>
-        <p:txBody>
-          <a:bodyPr wrap="square">
-            <a:spAutoFit/>
-          </a:bodyPr>
-          <a:lstStyle/>
-          <a:p/>
-          <a:p>
-            <a:pPr>
-              <a:spcBef>
-                <a:spcPts val="600"/>
-              </a:spcBef>
-              <a:defRPr sz="1200" b="1">
-                <a:solidFill>
-                  <a:srgbClr val="7C3AED"/>
-                </a:solidFill>
-              </a:defRPr>
-            </a:pPr>
-            <a:r>
-              <a:t>Q3: Why was scaling and log1p mandatory before clustering?</a:t>
-            </a:r>
-          </a:p>
-          <a:p>
-            <a:pPr>
-              <a:spcBef>
-                <a:spcPts val="300"/>
-              </a:spcBef>
-              <a:defRPr sz="1050">
-                <a:solidFill>
-                  <a:srgbClr val="0F172A"/>
-                </a:solidFill>
-              </a:defRPr>
-            </a:pPr>
-            <a:r>
-              <a:t>A: Distance algorithms calculate sqrt(sum(x_i - y_i)^2). Because Monetary ranges up to £100,000 while Frequency is &lt;50, Monetary squared differences would dominate by 1,000,000x, ignoring purchase recency completely without log-scaling.</a:t>
-            </a:r>
-          </a:p>
-          <a:p>
-            <a:pPr>
-              <a:spcBef>
-                <a:spcPts val="600"/>
-              </a:spcBef>
-              <a:defRPr sz="1200" b="1">
-                <a:solidFill>
-                  <a:srgbClr val="7C3AED"/>
-                </a:solidFill>
-              </a:defRPr>
-            </a:pPr>
-            <a:r>
-              <a:t>Q4: How did you satisfy Section 3.3 regarding ground-truth labels?</a:t>
-            </a:r>
-          </a:p>
-          <a:p>
-            <a:pPr>
-              <a:spcBef>
-                <a:spcPts val="300"/>
-              </a:spcBef>
-              <a:defRPr sz="1050">
-                <a:solidFill>
-                  <a:srgbClr val="0F172A"/>
-                </a:solidFill>
-              </a:defRPr>
-            </a:pPr>
-            <a:r>
-              <a:t>A: Repeat_Customer was strictly omitted during model fitting. It was used only in post-hoc cross-tabulation to demonstrate that Cluster 1 naturally captures 100% repeat buyers and Cluster 2 captures 75% one-time buyers.</a:t>
-            </a:r>
-          </a:p>
-        </p:txBody>
-      </p:sp>
-    </p:spTree>
-  </p:cSld>
-  <p:clrMapOvr>
-    <a:masterClrMapping/>
-  </p:clrMapOvr>
-</p:sld>
-</file>
-
-<file path=ppt/slides/slide24.xml><?xml version="1.0" encoding="utf-8"?>
-<p:sld xmlns:a="http://schemas.openxmlformats.org/drawingml/2006/main" xmlns:p="http://schemas.openxmlformats.org/presentationml/2006/main" xmlns:r="http://schemas.openxmlformats.org/officeDocument/2006/relationships">
-  <p:cSld>
-    <p:spTree>
-      <p:nvGrpSpPr>
-        <p:cNvPr id="1" name=""/>
-        <p:cNvGrpSpPr/>
-        <p:nvPr/>
-      </p:nvGrpSpPr>
-      <p:grpSpPr/>
-      <p:sp>
-        <p:nvSpPr>
-          <p:cNvPr id="2" name="TextBox 1"/>
-          <p:cNvSpPr txBox="1"/>
-          <p:nvPr/>
-        </p:nvSpPr>
-        <p:spPr>
-          <a:xfrm>
-            <a:off x="731520" y="365760"/>
-            <a:ext cx="7772400" cy="320040"/>
-          </a:xfrm>
-          <a:prstGeom prst="rect">
-            <a:avLst/>
-          </a:prstGeom>
-          <a:noFill/>
-        </p:spPr>
-        <p:txBody>
-          <a:bodyPr wrap="square">
-            <a:spAutoFit/>
-          </a:bodyPr>
-          <a:lstStyle/>
-          <a:p>
-            <a:pPr>
-              <a:defRPr sz="1000" b="1">
-                <a:solidFill>
-                  <a:srgbClr val="2563EB"/>
-                </a:solidFill>
-              </a:defRPr>
-            </a:pPr>
-            <a:r>
               <a:t>CAPSTONE REVIEW 2 EVALUATION SUMMARY</a:t>
             </a:r>
           </a:p>
@@ -15088,7 +13780,7 @@
               </a:defRPr>
             </a:pPr>
             <a:r>
-              <a:t>Member 1 Key Insights</a:t>
+              <a:t>Error Distribution Analysis</a:t>
             </a:r>
           </a:p>
           <a:p>
@@ -15504,7 +14196,7 @@
               </a:defRPr>
             </a:pPr>
             <a:r>
-              <a:t>Viva Meaning: ROC-AUC evaluates probability calibration independent of an arbitrary 0.5 decision cut-off threshold.</a:t>
+              <a:t>Ranking Metric Meaning: ROC-AUC evaluates probability calibration independent of an arbitrary 0.5 decision cut-off threshold.</a:t>
             </a:r>
           </a:p>
         </p:txBody>
@@ -15785,7 +14477,7 @@
               </a:defRPr>
             </a:pPr>
             <a:r>
-              <a:t>Business &amp; Technical Interpretation</a:t>
+              <a:t>Technical Feature Interpretation</a:t>
             </a:r>
           </a:p>
           <a:p>
@@ -18103,7 +16795,7 @@
               </a:defRPr>
             </a:pPr>
             <a:r>
-              <a:t>Member 2 Tuning Strategy</a:t>
+              <a:t>Model Selection Justification</a:t>
             </a:r>
           </a:p>
           <a:p>

</xml_diff>

<commit_message>
Fix dendrogram cut threshold to y=20 so it cuts exactly 4 branches for k=4
</commit_message>
<xml_diff>
--- a/Review_2_Presentation_Team.pptx
+++ b/Review_2_Presentation_Team.pptx
@@ -6517,30 +6517,6 @@
           </a:p>
         </p:txBody>
       </p:sp>
-      <p:pic>
-        <p:nvPicPr>
-          <p:cNvPr id="6" name="Picture 5" descr="clustering_dendrogram.png"/>
-          <p:cNvPicPr>
-            <a:picLocks noChangeAspect="1"/>
-          </p:cNvPicPr>
-          <p:nvPr/>
-        </p:nvPicPr>
-        <p:blipFill>
-          <a:blip r:embed="rId2"/>
-          <a:stretch>
-            <a:fillRect/>
-          </a:stretch>
-        </p:blipFill>
-        <p:spPr>
-          <a:xfrm>
-            <a:off x="731520" y="1828800"/>
-            <a:ext cx="6766560" cy="3323034"/>
-          </a:xfrm>
-          <a:prstGeom prst="rect">
-            <a:avLst/>
-          </a:prstGeom>
-        </p:spPr>
-      </p:pic>
       <p:sp>
         <p:nvSpPr>
           <p:cNvPr id="7" name="Rounded Rectangle 6"/>
@@ -6661,7 +6637,7 @@
               </a:defRPr>
             </a:pPr>
             <a:r>
-              <a:t>Horizontal Cut Threshold: Cutting the dendrogram at Euclidean distance threshold y = 25 yields exactly 4 major branches, corroborating K-Means k = 4!</a:t>
+              <a:t>Horizontal Cut Threshold: Cutting the dendrogram at Euclidean distance threshold y = 20 yields exactly 4 major branches, corroborating K-Means k = 4!</a:t>
             </a:r>
           </a:p>
           <a:p>
@@ -6681,6 +6657,30 @@
           </a:p>
         </p:txBody>
       </p:sp>
+      <p:pic>
+        <p:nvPicPr>
+          <p:cNvPr id="9" name="Picture 8" descr="clustering_dendrogram.png"/>
+          <p:cNvPicPr>
+            <a:picLocks noChangeAspect="1"/>
+          </p:cNvPicPr>
+          <p:nvPr/>
+        </p:nvPicPr>
+        <p:blipFill>
+          <a:blip r:embed="rId3"/>
+          <a:stretch>
+            <a:fillRect/>
+          </a:stretch>
+        </p:blipFill>
+        <p:spPr>
+          <a:xfrm>
+            <a:off x="731520" y="1828800"/>
+            <a:ext cx="6766560" cy="3323034"/>
+          </a:xfrm>
+          <a:prstGeom prst="rect">
+            <a:avLst/>
+          </a:prstGeom>
+        </p:spPr>
+      </p:pic>
     </p:spTree>
   </p:cSld>
   <p:clrMapOvr>

</xml_diff>